<commit_message>
Cut the cross-model figure to hit rate / TTFT / host DRAM
Drops the throughput panel from both the PDF and the slide. Closed-loop it is
flat by construction, and the open-loop sweep showed why that does not change
under load: the server saturates on decode, which KV placement does not touch
(peak 1105 / 1249 / 1135 tok/s across arms). Neither version separates the
arms, so neither earns a third of the figure.

Co-Authored-By: Claude Opus 5 <noreply@anthropic.com>
Claude-Session: https://claude.ai/code/session_01AoK4pG7kwrWE4Xc7fqoTVf
</commit_message>
<xml_diff>
--- a/results/models/fig_models.pptx
+++ b/results/models/fig_models.pptx
@@ -1206,613 +1206,7 @@
                 </a:solidFill>
                 <a:latin typeface="Times New Roman"/>
               </a:rPr>
-              <a:t>(c)  Throughput</a:t>
-            </a:r>
-          </a:p>
-        </c:rich>
-      </c:tx>
-      <c:layout/>
-      <c:overlay val="0"/>
-    </c:title>
-    <c:autoTitleDeleted val="0"/>
-    <c:plotArea>
-      <c:layout/>
-      <c:barChart>
-        <c:barDir val="col"/>
-        <c:grouping val="clustered"/>
-        <c:varyColors val="0"/>
-        <c:ser>
-          <c:idx val="0"/>
-          <c:order val="0"/>
-          <c:tx>
-            <c:strRef>
-              <c:f>Sheet1!$B$1</c:f>
-              <c:strCache>
-                <c:ptCount val="1"/>
-                <c:pt idx="0">
-                  <c:v>Recompute</c:v>
-                </c:pt>
-              </c:strCache>
-            </c:strRef>
-          </c:tx>
-          <c:spPr>
-            <a:solidFill>
-              <a:srgbClr val="BFC4C9"/>
-            </a:solidFill>
-            <a:effectLst/>
-          </c:spPr>
-          <c:invertIfNegative val="0"/>
-          <c:dLbls>
-            <c:numFmt formatCode="#,##0" sourceLinked="0"/>
-            <c:txPr>
-              <a:bodyPr/>
-              <a:lstStyle/>
-              <a:p>
-                <a:pPr>
-                  <a:defRPr b="0" i="0" strike="noStrike" sz="1200" u="none">
-                    <a:solidFill>
-                      <a:srgbClr val="000000"/>
-                    </a:solidFill>
-                    <a:latin typeface="Arial"/>
-                  </a:defRPr>
-                </a:pPr>
-              </a:p>
-            </c:txPr>
-            <c:showLegendKey val="0"/>
-            <c:showVal val="0"/>
-            <c:showCatName val="0"/>
-            <c:showSerName val="0"/>
-            <c:showPercent val="0"/>
-            <c:showBubbleSize val="0"/>
-            <c:showLeaderLines val="0"/>
-          </c:dLbls>
-          <c:cat>
-            <c:multiLvlStrRef>
-              <c:f>Sheet1!$A$2:$A$4</c:f>
-              <c:multiLvlStrCache>
-                <c:ptCount val="3"/>
-                <c:lvl>
-                  <c:pt idx="0">
-                    <c:v>Llama-3.1-8B</c:v>
-                  </c:pt>
-                  <c:pt idx="1">
-                    <c:v>Llama-2-13B</c:v>
-                  </c:pt>
-                  <c:pt idx="2">
-                    <c:v>Qwen3-14B</c:v>
-                  </c:pt>
-                </c:lvl>
-              </c:multiLvlStrCache>
-            </c:multiLvlStrRef>
-          </c:cat>
-          <c:val>
-            <c:numRef>
-              <c:f>Sheet1!$B$2:$B$4</c:f>
-              <c:numCache>
-                <c:formatCode>General</c:formatCode>
-                <c:ptCount val="3"/>
-                <c:pt idx="0">
-                  <c:v>1</c:v>
-                </c:pt>
-                <c:pt idx="1">
-                  <c:v>1</c:v>
-                </c:pt>
-                <c:pt idx="2">
-                  <c:v>1</c:v>
-                </c:pt>
-              </c:numCache>
-            </c:numRef>
-          </c:val>
-        </c:ser>
-        <c:ser>
-          <c:idx val="1"/>
-          <c:order val="1"/>
-          <c:tx>
-            <c:strRef>
-              <c:f>Sheet1!$C$1</c:f>
-              <c:strCache>
-                <c:ptCount val="1"/>
-                <c:pt idx="0">
-                  <c:v>SGLang</c:v>
-                </c:pt>
-              </c:strCache>
-            </c:strRef>
-          </c:tx>
-          <c:spPr>
-            <a:solidFill>
-              <a:srgbClr val="0072B2"/>
-            </a:solidFill>
-            <a:effectLst/>
-          </c:spPr>
-          <c:invertIfNegative val="0"/>
-          <c:dLbls>
-            <c:numFmt formatCode="#,##0" sourceLinked="0"/>
-            <c:txPr>
-              <a:bodyPr/>
-              <a:lstStyle/>
-              <a:p>
-                <a:pPr>
-                  <a:defRPr b="0" i="0" strike="noStrike" sz="1200" u="none">
-                    <a:solidFill>
-                      <a:srgbClr val="000000"/>
-                    </a:solidFill>
-                    <a:latin typeface="Arial"/>
-                  </a:defRPr>
-                </a:pPr>
-              </a:p>
-            </c:txPr>
-            <c:showLegendKey val="0"/>
-            <c:showVal val="0"/>
-            <c:showCatName val="0"/>
-            <c:showSerName val="0"/>
-            <c:showPercent val="0"/>
-            <c:showBubbleSize val="0"/>
-            <c:showLeaderLines val="0"/>
-          </c:dLbls>
-          <c:cat>
-            <c:multiLvlStrRef>
-              <c:f>Sheet1!$A$2:$A$4</c:f>
-              <c:multiLvlStrCache>
-                <c:ptCount val="3"/>
-                <c:lvl>
-                  <c:pt idx="0">
-                    <c:v>Llama-3.1-8B</c:v>
-                  </c:pt>
-                  <c:pt idx="1">
-                    <c:v>Llama-2-13B</c:v>
-                  </c:pt>
-                  <c:pt idx="2">
-                    <c:v>Qwen3-14B</c:v>
-                  </c:pt>
-                </c:lvl>
-              </c:multiLvlStrCache>
-            </c:multiLvlStrRef>
-          </c:cat>
-          <c:val>
-            <c:numRef>
-              <c:f>Sheet1!$C$2:$C$4</c:f>
-              <c:numCache>
-                <c:formatCode>General</c:formatCode>
-                <c:ptCount val="3"/>
-                <c:pt idx="0">
-                  <c:v>1.013</c:v>
-                </c:pt>
-                <c:pt idx="1">
-                  <c:v>0.994</c:v>
-                </c:pt>
-                <c:pt idx="2">
-                  <c:v>1.002</c:v>
-                </c:pt>
-              </c:numCache>
-            </c:numRef>
-          </c:val>
-        </c:ser>
-        <c:ser>
-          <c:idx val="2"/>
-          <c:order val="2"/>
-          <c:tx>
-            <c:strRef>
-              <c:f>Sheet1!$D$1</c:f>
-              <c:strCache>
-                <c:ptCount val="1"/>
-                <c:pt idx="0">
-                  <c:v>Ours</c:v>
-                </c:pt>
-              </c:strCache>
-            </c:strRef>
-          </c:tx>
-          <c:spPr>
-            <a:solidFill>
-              <a:srgbClr val="009E73"/>
-            </a:solidFill>
-            <a:effectLst/>
-          </c:spPr>
-          <c:invertIfNegative val="0"/>
-          <c:dLbls>
-            <c:numFmt formatCode="#,##0" sourceLinked="0"/>
-            <c:txPr>
-              <a:bodyPr/>
-              <a:lstStyle/>
-              <a:p>
-                <a:pPr>
-                  <a:defRPr b="0" i="0" strike="noStrike" sz="1200" u="none">
-                    <a:solidFill>
-                      <a:srgbClr val="000000"/>
-                    </a:solidFill>
-                    <a:latin typeface="Arial"/>
-                  </a:defRPr>
-                </a:pPr>
-              </a:p>
-            </c:txPr>
-            <c:showLegendKey val="0"/>
-            <c:showVal val="0"/>
-            <c:showCatName val="0"/>
-            <c:showSerName val="0"/>
-            <c:showPercent val="0"/>
-            <c:showBubbleSize val="0"/>
-            <c:showLeaderLines val="0"/>
-          </c:dLbls>
-          <c:cat>
-            <c:multiLvlStrRef>
-              <c:f>Sheet1!$A$2:$A$4</c:f>
-              <c:multiLvlStrCache>
-                <c:ptCount val="3"/>
-                <c:lvl>
-                  <c:pt idx="0">
-                    <c:v>Llama-3.1-8B</c:v>
-                  </c:pt>
-                  <c:pt idx="1">
-                    <c:v>Llama-2-13B</c:v>
-                  </c:pt>
-                  <c:pt idx="2">
-                    <c:v>Qwen3-14B</c:v>
-                  </c:pt>
-                </c:lvl>
-              </c:multiLvlStrCache>
-            </c:multiLvlStrRef>
-          </c:cat>
-          <c:val>
-            <c:numRef>
-              <c:f>Sheet1!$D$2:$D$4</c:f>
-              <c:numCache>
-                <c:formatCode>General</c:formatCode>
-                <c:ptCount val="3"/>
-                <c:pt idx="0">
-                  <c:v>1.008</c:v>
-                </c:pt>
-                <c:pt idx="1">
-                  <c:v>0.999</c:v>
-                </c:pt>
-                <c:pt idx="2">
-                  <c:v>1.001</c:v>
-                </c:pt>
-              </c:numCache>
-            </c:numRef>
-          </c:val>
-        </c:ser>
-        <c:dLbls>
-          <c:numFmt formatCode="#,##0" sourceLinked="0"/>
-          <c:txPr>
-            <a:bodyPr/>
-            <a:lstStyle/>
-            <a:p>
-              <a:pPr>
-                <a:defRPr b="0" i="0" strike="noStrike" sz="1200" u="none">
-                  <a:solidFill>
-                    <a:srgbClr val="000000"/>
-                  </a:solidFill>
-                  <a:latin typeface="Arial"/>
-                </a:defRPr>
-              </a:pPr>
-            </a:p>
-          </c:txPr>
-          <c:showLegendKey val="0"/>
-          <c:showVal val="0"/>
-          <c:showCatName val="0"/>
-          <c:showSerName val="0"/>
-          <c:showPercent val="0"/>
-          <c:showBubbleSize val="0"/>
-          <c:showLeaderLines val="0"/>
-        </c:dLbls>
-        <c:gapWidth val="90"/>
-        <c:overlap val="0"/>
-        <c:axId val="2094734554"/>
-        <c:axId val="2094734552"/>
-        <c:axId val="2094734556"/>
-      </c:barChart>
-      <c:lineChart>
-        <c:varyColors val="0"/>
-        <c:ser>
-          <c:idx val="3"/>
-          <c:order val="3"/>
-          <c:tx>
-            <c:strRef>
-              <c:f>Sheet1!$E$1</c:f>
-              <c:strCache>
-                <c:ptCount val="1"/>
-                <c:pt idx="0">
-                  <c:v>Baseline (Recompute = 1.0)</c:v>
-                </c:pt>
-              </c:strCache>
-            </c:strRef>
-          </c:tx>
-          <c:spPr>
-            <a:solidFill>
-              <a:srgbClr val="1A1A1A"/>
-            </a:solidFill>
-            <a:ln w="19050" cap="flat">
-              <a:solidFill>
-                <a:srgbClr val="1A1A1A"/>
-              </a:solidFill>
-              <a:prstDash val="dash"/>
-              <a:round/>
-            </a:ln>
-            <a:effectLst/>
-          </c:spPr>
-          <c:invertIfNegative val="0"/>
-          <c:dLbls>
-            <c:numFmt formatCode="#,##0" sourceLinked="0"/>
-            <c:txPr>
-              <a:bodyPr/>
-              <a:lstStyle/>
-              <a:p>
-                <a:pPr>
-                  <a:defRPr b="0" i="0" strike="noStrike" sz="1200" u="none">
-                    <a:solidFill>
-                      <a:srgbClr val="000000"/>
-                    </a:solidFill>
-                    <a:latin typeface="Arial"/>
-                  </a:defRPr>
-                </a:pPr>
-              </a:p>
-            </c:txPr>
-            <c:showLegendKey val="0"/>
-            <c:showVal val="0"/>
-            <c:showCatName val="0"/>
-            <c:showSerName val="0"/>
-            <c:showPercent val="0"/>
-            <c:showBubbleSize val="0"/>
-            <c:showLeaderLines val="0"/>
-          </c:dLbls>
-          <c:marker>
-            <c:symbol val="none"/>
-            <c:size val="6"/>
-            <c:spPr>
-              <a:solidFill>
-                <a:srgbClr val="1A1A1A"/>
-              </a:solidFill>
-              <a:ln w="9525" cap="flat">
-                <a:solidFill>
-                  <a:srgbClr val="1A1A1A"/>
-                </a:solidFill>
-                <a:prstDash val="solid"/>
-                <a:round/>
-              </a:ln>
-              <a:effectLst/>
-            </c:spPr>
-          </c:marker>
-          <c:cat>
-            <c:multiLvlStrRef>
-              <c:f>Sheet1!$A$2:$A$4</c:f>
-              <c:multiLvlStrCache>
-                <c:ptCount val="3"/>
-                <c:lvl>
-                  <c:pt idx="0">
-                    <c:v>Llama-3.1-8B</c:v>
-                  </c:pt>
-                  <c:pt idx="1">
-                    <c:v>Llama-2-13B</c:v>
-                  </c:pt>
-                  <c:pt idx="2">
-                    <c:v>Qwen3-14B</c:v>
-                  </c:pt>
-                </c:lvl>
-              </c:multiLvlStrCache>
-            </c:multiLvlStrRef>
-          </c:cat>
-          <c:val>
-            <c:numRef>
-              <c:f>Sheet1!$E$2:$E$4</c:f>
-              <c:numCache>
-                <c:formatCode>General</c:formatCode>
-                <c:ptCount val="3"/>
-                <c:pt idx="0">
-                  <c:v>1</c:v>
-                </c:pt>
-                <c:pt idx="1">
-                  <c:v>1</c:v>
-                </c:pt>
-                <c:pt idx="2">
-                  <c:v>1</c:v>
-                </c:pt>
-              </c:numCache>
-            </c:numRef>
-          </c:val>
-          <c:smooth val="0"/>
-        </c:ser>
-        <c:dLbls>
-          <c:numFmt formatCode="#,##0" sourceLinked="0"/>
-          <c:txPr>
-            <a:bodyPr/>
-            <a:lstStyle/>
-            <a:p>
-              <a:pPr>
-                <a:defRPr b="0" i="0" strike="noStrike" sz="1200" u="none">
-                  <a:solidFill>
-                    <a:srgbClr val="000000"/>
-                  </a:solidFill>
-                  <a:latin typeface="Arial"/>
-                </a:defRPr>
-              </a:pPr>
-            </a:p>
-          </c:txPr>
-          <c:showLegendKey val="0"/>
-          <c:showVal val="0"/>
-          <c:showCatName val="0"/>
-          <c:showSerName val="0"/>
-          <c:showPercent val="0"/>
-          <c:showBubbleSize val="0"/>
-          <c:showLeaderLines val="0"/>
-        </c:dLbls>
-        <c:marker val="1"/>
-        <c:axId val="2094734554"/>
-        <c:axId val="2094734552"/>
-        <c:axId val="2094734556"/>
-      </c:lineChart>
-      <c:catAx>
-        <c:axId val="2094734554"/>
-        <c:scaling>
-          <c:orientation val="minMax"/>
-        </c:scaling>
-        <c:delete val="0"/>
-        <c:axPos val="b"/>
-        <c:numFmt formatCode="General" sourceLinked="1"/>
-        <c:majorTickMark val="out"/>
-        <c:minorTickMark val="none"/>
-        <c:tickLblPos val="low"/>
-        <c:spPr>
-          <a:ln w="12700" cap="flat">
-            <a:solidFill>
-              <a:srgbClr val="888888"/>
-            </a:solidFill>
-            <a:prstDash val="solid"/>
-            <a:round/>
-          </a:ln>
-        </c:spPr>
-        <c:txPr>
-          <a:bodyPr/>
-          <a:lstStyle/>
-          <a:p>
-            <a:pPr>
-              <a:defRPr sz="1000" b="0" i="0" u="none" strike="noStrike">
-                <a:solidFill>
-                  <a:srgbClr val="595959"/>
-                </a:solidFill>
-                <a:latin typeface="Times New Roman"/>
-              </a:defRPr>
-            </a:pPr>
-            <a:endParaRPr lang="en-US"/>
-          </a:p>
-        </c:txPr>
-        <c:crossAx val="2094734552"/>
-        <c:crosses val="autoZero"/>
-        <c:auto val="1"/>
-        <c:lblAlgn val="ctr"/>
-        <c:noMultiLvlLbl val="1"/>
-      </c:catAx>
-      <c:valAx>
-        <c:axId val="2094734552"/>
-        <c:scaling>
-          <c:orientation val="minMax"/>
-          <c:max val="1.25"/>
-          <c:min val="0"/>
-        </c:scaling>
-        <c:delete val="0"/>
-        <c:axPos val="l"/>
-        <c:majorGridlines>
-          <c:spPr>
-            <a:ln w="9525" cap="flat">
-              <a:solidFill>
-                <a:srgbClr val="D9D9D9"/>
-              </a:solidFill>
-              <a:prstDash val="solid"/>
-              <a:round/>
-            </a:ln>
-          </c:spPr>
-        </c:majorGridlines>
-        <c:title>
-          <c:tx>
-            <c:rich>
-              <a:bodyPr/>
-              <a:lstStyle/>
-              <a:p>
-                <a:pPr>
-                  <a:defRPr sz="1100" b="0" i="0" u="none" strike="noStrike">
-                    <a:solidFill>
-                      <a:srgbClr val="000000"/>
-                    </a:solidFill>
-                    <a:latin typeface="Times New Roman"/>
-                  </a:defRPr>
-                </a:pPr>
-                <a:r>
-                  <a:rPr sz="1100" b="0" i="0" u="none" strike="noStrike">
-                    <a:solidFill>
-                      <a:srgbClr val="000000"/>
-                    </a:solidFill>
-                    <a:latin typeface="Times New Roman"/>
-                  </a:rPr>
-                  <a:t>Normalized Throughput</a:t>
-                </a:r>
-              </a:p>
-            </c:rich>
-          </c:tx>
-          <c:layout/>
-          <c:overlay val="0"/>
-        </c:title>
-        <c:numFmt formatCode="General" sourceLinked="0"/>
-        <c:majorTickMark val="out"/>
-        <c:minorTickMark val="none"/>
-        <c:tickLblPos val="nextTo"/>
-        <c:spPr>
-          <a:ln w="12700" cap="flat">
-            <a:solidFill>
-              <a:srgbClr val="888888"/>
-            </a:solidFill>
-            <a:prstDash val="solid"/>
-            <a:round/>
-          </a:ln>
-        </c:spPr>
-        <c:txPr>
-          <a:bodyPr/>
-          <a:lstStyle/>
-          <a:p>
-            <a:pPr>
-              <a:defRPr sz="1000" b="0" i="0" u="none" strike="noStrike">
-                <a:solidFill>
-                  <a:srgbClr val="595959"/>
-                </a:solidFill>
-                <a:latin typeface="Times New Roman"/>
-              </a:defRPr>
-            </a:pPr>
-            <a:endParaRPr lang="en-US"/>
-          </a:p>
-        </c:txPr>
-        <c:crossAx val="2094734554"/>
-        <c:crosses val="autoZero"/>
-        <c:crossBetween val="between"/>
-        <c:majorUnit val="0.25"/>
-      </c:valAx>
-      <c:spPr>
-        <a:noFill/>
-        <a:ln>
-          <a:noFill/>
-        </a:ln>
-        <a:effectLst/>
-      </c:spPr>
-    </c:plotArea>
-    <c:plotVisOnly val="1"/>
-    <c:dispBlanksAs val="span"/>
-  </c:chart>
-  <c:spPr>
-    <a:noFill/>
-    <a:ln>
-      <a:noFill/>
-    </a:ln>
-    <a:effectLst/>
-  </c:spPr>
-  <c:externalData r:id="rId1">
-    <c:autoUpdate val="0"/>
-  </c:externalData>
-</c:chartSpace>
-</file>
-
-<file path=ppt/charts/chart4.xml><?xml version="1.0" encoding="utf-8"?>
-<c:chartSpace xmlns:c="http://schemas.openxmlformats.org/drawingml/2006/chart" xmlns:a="http://schemas.openxmlformats.org/drawingml/2006/main" xmlns:r="http://schemas.openxmlformats.org/officeDocument/2006/relationships">
-  <c:date1904 val="0"/>
-  <c:roundedCorners val="1"/>
-  <c:chart>
-    <c:title>
-      <c:tx>
-        <c:rich>
-          <a:bodyPr/>
-          <a:lstStyle/>
-          <a:p>
-            <a:pPr>
-              <a:defRPr sz="1300" b="0" i="0" u="none" strike="noStrike">
-                <a:solidFill>
-                  <a:srgbClr val="1A1A1A"/>
-                </a:solidFill>
-                <a:latin typeface="Times New Roman"/>
-              </a:defRPr>
-            </a:pPr>
-            <a:r>
-              <a:rPr sz="1300" b="0" i="0" u="none" strike="noStrike">
-                <a:solidFill>
-                  <a:srgbClr val="1A1A1A"/>
-                </a:solidFill>
-                <a:latin typeface="Times New Roman"/>
-              </a:rPr>
-              <a:t>(d)  Host memory</a:t>
+              <a:t>(c)  Host memory</a:t>
             </a:r>
           </a:p>
         </c:rich>
@@ -3101,8 +2495,8 @@
           <p:nvPr/>
         </p:nvGraphicFramePr>
         <p:xfrm>
-          <a:off x="411480" y="1051560"/>
-          <a:ext cx="2761488" cy="3931920"/>
+          <a:off x="640080" y="1051560"/>
+          <a:ext cx="3520440" cy="3931920"/>
         </p:xfrm>
         <a:graphic xmlns:a="http://schemas.openxmlformats.org/drawingml/2006/main">
           <a:graphicData uri="http://schemas.openxmlformats.org/drawingml/2006/chart">
@@ -3118,8 +2512,8 @@
         </p:nvSpPr>
         <p:spPr>
           <a:xfrm>
-            <a:off x="667512" y="1435608"/>
-            <a:ext cx="828446" cy="256032"/>
+            <a:off x="896112" y="1435608"/>
+            <a:ext cx="1056132" cy="256032"/>
           </a:xfrm>
           <a:prstGeom prst="rect">
             <a:avLst/>
@@ -3157,8 +2551,8 @@
         </p:nvSpPr>
         <p:spPr>
           <a:xfrm>
-            <a:off x="1514368" y="1435608"/>
-            <a:ext cx="828446" cy="256032"/>
+            <a:off x="1975714" y="1435608"/>
+            <a:ext cx="1056132" cy="256032"/>
           </a:xfrm>
           <a:prstGeom prst="rect">
             <a:avLst/>
@@ -3196,8 +2590,8 @@
         </p:nvSpPr>
         <p:spPr>
           <a:xfrm>
-            <a:off x="2361225" y="1435608"/>
-            <a:ext cx="828446" cy="256032"/>
+            <a:off x="3055315" y="1435608"/>
+            <a:ext cx="1056132" cy="256032"/>
           </a:xfrm>
           <a:prstGeom prst="rect">
             <a:avLst/>
@@ -3234,8 +2628,8 @@
           <p:nvPr/>
         </p:nvGraphicFramePr>
         <p:xfrm>
-          <a:off x="3291840" y="1051560"/>
-          <a:ext cx="2761488" cy="3931920"/>
+          <a:off x="4389120" y="1051560"/>
+          <a:ext cx="3520440" cy="3931920"/>
         </p:xfrm>
         <a:graphic xmlns:a="http://schemas.openxmlformats.org/drawingml/2006/main">
           <a:graphicData uri="http://schemas.openxmlformats.org/drawingml/2006/chart">
@@ -3251,8 +2645,8 @@
         </p:nvSpPr>
         <p:spPr>
           <a:xfrm>
-            <a:off x="3547872" y="1435608"/>
-            <a:ext cx="828446" cy="256032"/>
+            <a:off x="4645152" y="1435608"/>
+            <a:ext cx="1056132" cy="256032"/>
           </a:xfrm>
           <a:prstGeom prst="rect">
             <a:avLst/>
@@ -3290,8 +2684,8 @@
         </p:nvSpPr>
         <p:spPr>
           <a:xfrm>
-            <a:off x="4394728" y="1435608"/>
-            <a:ext cx="828446" cy="256032"/>
+            <a:off x="5724754" y="1435608"/>
+            <a:ext cx="1056132" cy="256032"/>
           </a:xfrm>
           <a:prstGeom prst="rect">
             <a:avLst/>
@@ -3329,8 +2723,8 @@
         </p:nvSpPr>
         <p:spPr>
           <a:xfrm>
-            <a:off x="5241585" y="1435608"/>
-            <a:ext cx="828446" cy="256032"/>
+            <a:off x="6804355" y="1435608"/>
+            <a:ext cx="1056132" cy="256032"/>
           </a:xfrm>
           <a:prstGeom prst="rect">
             <a:avLst/>
@@ -3367,8 +2761,8 @@
           <p:nvPr/>
         </p:nvGraphicFramePr>
         <p:xfrm>
-          <a:off x="6172200" y="1051560"/>
-          <a:ext cx="2761488" cy="3931920"/>
+          <a:off x="8138160" y="1051560"/>
+          <a:ext cx="3520440" cy="3931920"/>
         </p:xfrm>
         <a:graphic xmlns:a="http://schemas.openxmlformats.org/drawingml/2006/main">
           <a:graphicData uri="http://schemas.openxmlformats.org/drawingml/2006/chart">
@@ -3384,141 +2778,8 @@
         </p:nvSpPr>
         <p:spPr>
           <a:xfrm>
-            <a:off x="6428232" y="1435608"/>
-            <a:ext cx="828446" cy="256032"/>
-          </a:xfrm>
-          <a:prstGeom prst="rect">
-            <a:avLst/>
-          </a:prstGeom>
-          <a:noFill/>
-          <a:ln/>
-        </p:spPr>
-        <p:txBody>
-          <a:bodyPr wrap="square" lIns="0" tIns="0" rIns="0" bIns="0" rtlCol="0" anchor="ctr"/>
-          <a:lstStyle/>
-          <a:p>
-            <a:pPr algn="ctr" indent="0" marL="0">
-              <a:buNone/>
-            </a:pPr>
-            <a:r>
-              <a:rPr lang="en-US" sz="1200" b="1" dirty="0">
-                <a:solidFill>
-                  <a:srgbClr val="1A1A1A"/>
-                </a:solidFill>
-                <a:latin typeface="Times New Roman" pitchFamily="34" charset="0"/>
-                <a:ea typeface="Times New Roman" pitchFamily="34" charset="-122"/>
-                <a:cs typeface="Times New Roman" pitchFamily="34" charset="-120"/>
-              </a:rPr>
-              <a:t>0.99×</a:t>
-            </a:r>
-            <a:endParaRPr lang="en-US" sz="1200" dirty="0"/>
-          </a:p>
-        </p:txBody>
-      </p:sp>
-      <p:sp>
-        <p:nvSpPr>
-          <p:cNvPr id="14" name="Text 9"/>
-          <p:cNvSpPr/>
-          <p:nvPr/>
-        </p:nvSpPr>
-        <p:spPr>
-          <a:xfrm>
-            <a:off x="7275088" y="1435608"/>
-            <a:ext cx="828446" cy="256032"/>
-          </a:xfrm>
-          <a:prstGeom prst="rect">
-            <a:avLst/>
-          </a:prstGeom>
-          <a:noFill/>
-          <a:ln/>
-        </p:spPr>
-        <p:txBody>
-          <a:bodyPr wrap="square" lIns="0" tIns="0" rIns="0" bIns="0" rtlCol="0" anchor="ctr"/>
-          <a:lstStyle/>
-          <a:p>
-            <a:pPr algn="ctr" indent="0" marL="0">
-              <a:buNone/>
-            </a:pPr>
-            <a:r>
-              <a:rPr lang="en-US" sz="1200" b="1" dirty="0">
-                <a:solidFill>
-                  <a:srgbClr val="1A1A1A"/>
-                </a:solidFill>
-                <a:latin typeface="Times New Roman" pitchFamily="34" charset="0"/>
-                <a:ea typeface="Times New Roman" pitchFamily="34" charset="-122"/>
-                <a:cs typeface="Times New Roman" pitchFamily="34" charset="-120"/>
-              </a:rPr>
-              <a:t>1.00×</a:t>
-            </a:r>
-            <a:endParaRPr lang="en-US" sz="1200" dirty="0"/>
-          </a:p>
-        </p:txBody>
-      </p:sp>
-      <p:sp>
-        <p:nvSpPr>
-          <p:cNvPr id="15" name="Text 10"/>
-          <p:cNvSpPr/>
-          <p:nvPr/>
-        </p:nvSpPr>
-        <p:spPr>
-          <a:xfrm>
-            <a:off x="8121945" y="1435608"/>
-            <a:ext cx="828446" cy="256032"/>
-          </a:xfrm>
-          <a:prstGeom prst="rect">
-            <a:avLst/>
-          </a:prstGeom>
-          <a:noFill/>
-          <a:ln/>
-        </p:spPr>
-        <p:txBody>
-          <a:bodyPr wrap="square" lIns="0" tIns="0" rIns="0" bIns="0" rtlCol="0" anchor="ctr"/>
-          <a:lstStyle/>
-          <a:p>
-            <a:pPr algn="ctr" indent="0" marL="0">
-              <a:buNone/>
-            </a:pPr>
-            <a:r>
-              <a:rPr lang="en-US" sz="1200" b="1" dirty="0">
-                <a:solidFill>
-                  <a:srgbClr val="1A1A1A"/>
-                </a:solidFill>
-                <a:latin typeface="Times New Roman" pitchFamily="34" charset="0"/>
-                <a:ea typeface="Times New Roman" pitchFamily="34" charset="-122"/>
-                <a:cs typeface="Times New Roman" pitchFamily="34" charset="-120"/>
-              </a:rPr>
-              <a:t>1.00×</a:t>
-            </a:r>
-            <a:endParaRPr lang="en-US" sz="1200" dirty="0"/>
-          </a:p>
-        </p:txBody>
-      </p:sp>
-      <p:graphicFrame>
-        <p:nvGraphicFramePr>
-          <p:cNvPr id="16" name="Chart 3" descr=""/>
-          <p:cNvGraphicFramePr/>
-          <p:nvPr/>
-        </p:nvGraphicFramePr>
-        <p:xfrm>
-          <a:off x="9052560" y="1051560"/>
-          <a:ext cx="2761488" cy="3931920"/>
-        </p:xfrm>
-        <a:graphic xmlns:a="http://schemas.openxmlformats.org/drawingml/2006/main">
-          <a:graphicData uri="http://schemas.openxmlformats.org/drawingml/2006/chart">
-            <c:chart xmlns:c="http://schemas.openxmlformats.org/drawingml/2006/chart" r:id="rId4"/>
-          </a:graphicData>
-        </a:graphic>
-      </p:graphicFrame>
-      <p:sp>
-        <p:nvSpPr>
-          <p:cNvPr id="17" name="Text 11"/>
-          <p:cNvSpPr/>
-          <p:nvPr/>
-        </p:nvSpPr>
-        <p:spPr>
-          <a:xfrm>
-            <a:off x="9308592" y="1435608"/>
-            <a:ext cx="828446" cy="256032"/>
+            <a:off x="8394192" y="1435608"/>
+            <a:ext cx="1056132" cy="256032"/>
           </a:xfrm>
           <a:prstGeom prst="rect">
             <a:avLst/>
@@ -3550,14 +2811,14 @@
       </p:sp>
       <p:sp>
         <p:nvSpPr>
-          <p:cNvPr id="18" name="Text 12"/>
+          <p:cNvPr id="14" name="Text 9"/>
           <p:cNvSpPr/>
           <p:nvPr/>
         </p:nvSpPr>
         <p:spPr>
           <a:xfrm>
-            <a:off x="10155448" y="1435608"/>
-            <a:ext cx="828446" cy="256032"/>
+            <a:off x="9473794" y="1435608"/>
+            <a:ext cx="1056132" cy="256032"/>
           </a:xfrm>
           <a:prstGeom prst="rect">
             <a:avLst/>
@@ -3589,14 +2850,14 @@
       </p:sp>
       <p:sp>
         <p:nvSpPr>
-          <p:cNvPr id="19" name="Text 13"/>
+          <p:cNvPr id="15" name="Text 10"/>
           <p:cNvSpPr/>
           <p:nvPr/>
         </p:nvSpPr>
         <p:spPr>
           <a:xfrm>
-            <a:off x="11002305" y="1435608"/>
-            <a:ext cx="828446" cy="256032"/>
+            <a:off x="10553395" y="1435608"/>
+            <a:ext cx="1056132" cy="256032"/>
           </a:xfrm>
           <a:prstGeom prst="rect">
             <a:avLst/>
@@ -3628,7 +2889,7 @@
       </p:sp>
       <p:sp>
         <p:nvSpPr>
-          <p:cNvPr id="20" name="Shape 14"/>
+          <p:cNvPr id="16" name="Shape 11"/>
           <p:cNvSpPr/>
           <p:nvPr/>
         </p:nvSpPr>
@@ -3653,7 +2914,7 @@
       </p:sp>
       <p:sp>
         <p:nvSpPr>
-          <p:cNvPr id="21" name="Text 15"/>
+          <p:cNvPr id="17" name="Text 12"/>
           <p:cNvSpPr/>
           <p:nvPr/>
         </p:nvSpPr>
@@ -3692,7 +2953,7 @@
       </p:sp>
       <p:sp>
         <p:nvSpPr>
-          <p:cNvPr id="22" name="Shape 16"/>
+          <p:cNvPr id="18" name="Shape 13"/>
           <p:cNvSpPr/>
           <p:nvPr/>
         </p:nvSpPr>
@@ -3717,7 +2978,7 @@
       </p:sp>
       <p:sp>
         <p:nvSpPr>
-          <p:cNvPr id="23" name="Text 17"/>
+          <p:cNvPr id="19" name="Text 14"/>
           <p:cNvSpPr/>
           <p:nvPr/>
         </p:nvSpPr>
@@ -3756,7 +3017,7 @@
       </p:sp>
       <p:sp>
         <p:nvSpPr>
-          <p:cNvPr id="24" name="Shape 18"/>
+          <p:cNvPr id="20" name="Shape 15"/>
           <p:cNvSpPr/>
           <p:nvPr/>
         </p:nvSpPr>
@@ -3781,7 +3042,7 @@
       </p:sp>
       <p:sp>
         <p:nvSpPr>
-          <p:cNvPr id="25" name="Text 19"/>
+          <p:cNvPr id="21" name="Text 16"/>
           <p:cNvSpPr/>
           <p:nvPr/>
         </p:nvSpPr>
@@ -3820,7 +3081,7 @@
       </p:sp>
       <p:sp>
         <p:nvSpPr>
-          <p:cNvPr id="26" name="Text 20"/>
+          <p:cNvPr id="22" name="Text 17"/>
           <p:cNvSpPr/>
           <p:nvPr/>
         </p:nvSpPr>
@@ -3851,7 +3112,7 @@
                 <a:ea typeface="Times New Roman" pitchFamily="34" charset="-122"/>
                 <a:cs typeface="Times New Roman" pitchFamily="34" charset="-120"/>
               </a:rPr>
-              <a:t>Hit rate and host DRAM improve on all three models. Throughput is flat by construction — the benchmark is closed-loop, so every arm does the same work in the same wall time. Normalized TTFT is the exception on Llama-2-13B (0.95×): its 4096-position limit caps conversations at four turns, so the re-prefill a hit avoids is small enough that the fetch does not pay for itself — the mechanism still works there (1.66× hit rate), it just has less to win.</a:t>
+              <a:t>Hit rate and host DRAM improve on all three models. Normalized TTFT is the exception on Llama-2-13B (0.95×): its 4096-position limit caps conversations at four turns, so the re-prefill a hit avoids is small enough that the fetch does not pay for itself — the mechanism still works there (1.66× hit rate), it just has less to win.</a:t>
             </a:r>
             <a:endParaRPr lang="en-US" sz="1100" dirty="0"/>
           </a:p>

</xml_diff>